<commit_message>
Compact architecture diagram with business case + tech stack on single slide
https://claude.ai/code/session_014wS2DvU2eo7vHVANX21pBq
</commit_message>
<xml_diff>
--- a/architecture_diagram2.pptx
+++ b/architecture_diagram2.pptx
@@ -3105,7 +3105,7 @@
         <p:spPr>
           <a:xfrm>
             <a:off x="0" y="0"/>
-            <a:ext cx="12188952" cy="301752"/>
+            <a:ext cx="12188952" cy="292608"/>
           </a:xfrm>
           <a:prstGeom prst="rect">
             <a:avLst/>
@@ -3137,103 +3137,27 @@
           <a:p>
             <a:pPr algn="ctr"/>
             <a:r>
-              <a:rPr b="1" sz="1400">
+              <a:rPr b="1" sz="1300">
                 <a:solidFill>
                   <a:srgbClr val="FFFFFF"/>
                 </a:solidFill>
                 <a:latin typeface="Calibri"/>
               </a:rPr>
               <a:t>Contract360  —  System Architecture</a:t>
-            </a:r>
-          </a:p>
-        </p:txBody>
-      </p:sp>
-      <p:sp>
-        <p:nvSpPr>
-          <p:cNvPr id="3" name="TextBox 2"/>
-          <p:cNvSpPr txBox="1"/>
-          <p:nvPr/>
-        </p:nvSpPr>
-        <p:spPr>
-          <a:xfrm>
-            <a:off x="182880" y="320040"/>
-            <a:ext cx="5029200" cy="201168"/>
-          </a:xfrm>
-          <a:prstGeom prst="rect">
-            <a:avLst/>
-          </a:prstGeom>
-          <a:noFill/>
-          <a:ln>
-            <a:noFill/>
-          </a:ln>
-        </p:spPr>
-        <p:txBody>
-          <a:bodyPr wrap="none">
-            <a:spAutoFit/>
-          </a:bodyPr>
-          <a:lstStyle/>
-          <a:p>
-            <a:pPr algn="l"/>
-            <a:r>
-              <a:rPr b="1" sz="750">
-                <a:solidFill>
-                  <a:srgbClr val="3FB950"/>
-                </a:solidFill>
-                <a:latin typeface="Calibri"/>
-              </a:rPr>
-              <a:t>◀  INGESTION PATH</a:t>
-            </a:r>
-          </a:p>
-        </p:txBody>
-      </p:sp>
-      <p:sp>
-        <p:nvSpPr>
-          <p:cNvPr id="4" name="TextBox 3"/>
-          <p:cNvSpPr txBox="1"/>
-          <p:nvPr/>
-        </p:nvSpPr>
-        <p:spPr>
-          <a:xfrm>
-            <a:off x="5669280" y="320040"/>
-            <a:ext cx="6217920" cy="201168"/>
-          </a:xfrm>
-          <a:prstGeom prst="rect">
-            <a:avLst/>
-          </a:prstGeom>
-          <a:noFill/>
-          <a:ln>
-            <a:noFill/>
-          </a:ln>
-        </p:spPr>
-        <p:txBody>
-          <a:bodyPr wrap="none">
-            <a:spAutoFit/>
-          </a:bodyPr>
-          <a:lstStyle/>
-          <a:p>
-            <a:pPr algn="r"/>
-            <a:r>
-              <a:rPr b="1" sz="750">
-                <a:solidFill>
-                  <a:srgbClr val="79C0FF"/>
-                </a:solidFill>
-                <a:latin typeface="Calibri"/>
-              </a:rPr>
-              <a:t>QUERY PATH  ▶</a:t>
             </a:r>
           </a:p>
         </p:txBody>
       </p:sp>
       <p:cxnSp>
         <p:nvCxnSpPr>
-          <p:cNvPr id="5" name="Connector 4"/>
+          <p:cNvPr id="3" name="Connector 2"/>
           <p:cNvCxnSpPr/>
           <p:nvPr/>
         </p:nvCxnSpPr>
         <p:spPr>
           <a:xfrm>
-            <a:off x="5486400" y="320040"/>
-            <a:ext cx="0" cy="5550408"/>
+            <a:off x="7818120" y="292608"/>
+            <a:ext cx="0" cy="6565392"/>
           </a:xfrm>
           <a:prstGeom prst="line">
             <a:avLst/>
@@ -3262,18 +3186,18 @@
       </p:cxnSp>
       <p:sp>
         <p:nvSpPr>
-          <p:cNvPr id="6" name="Rounded Rectangle 5"/>
+          <p:cNvPr id="4" name="Rounded Rectangle 3"/>
           <p:cNvSpPr/>
           <p:nvPr/>
         </p:nvSpPr>
         <p:spPr>
           <a:xfrm>
-            <a:off x="182880" y="365760"/>
-            <a:ext cx="11823192" cy="475488"/>
+            <a:off x="137160" y="320040"/>
+            <a:ext cx="7543800" cy="429768"/>
           </a:xfrm>
           <a:prstGeom prst="roundRect">
             <a:avLst>
-              <a:gd name="adj" fmla="val 15384"/>
+              <a:gd name="adj" fmla="val 8000"/>
             </a:avLst>
           </a:prstGeom>
           <a:solidFill>
@@ -3305,7 +3229,7 @@
           <a:p>
             <a:pPr algn="ctr"/>
             <a:r>
-              <a:rPr b="1" sz="1100">
+              <a:rPr b="1" sz="1000">
                 <a:solidFill>
                   <a:srgbClr val="FFFFFF"/>
                 </a:solidFill>
@@ -3317,37 +3241,37 @@
           <a:p>
             <a:pPr algn="ctr"/>
             <a:r>
-              <a:rPr b="0" sz="850">
+              <a:rPr b="0" sz="800">
                 <a:solidFill>
                   <a:srgbClr val="C9D1D9"/>
                 </a:solidFill>
                 <a:latin typeface="Calibri"/>
               </a:rPr>
-              <a:t>Chat  •  Contract Selector  •  Upload Panel  •  SSE Streaming  •  Citation Cards</a:t>
+              <a:t>Chat  •  Contract Selector  •  Upload  •  SSE Streaming  •  Citation Cards</a:t>
             </a:r>
           </a:p>
         </p:txBody>
       </p:sp>
       <p:cxnSp>
         <p:nvCxnSpPr>
-          <p:cNvPr id="7" name="Connector 6"/>
+          <p:cNvPr id="5" name="Connector 4"/>
           <p:cNvCxnSpPr/>
           <p:nvPr/>
         </p:nvCxnSpPr>
         <p:spPr>
           <a:xfrm>
-            <a:off x="6094476" y="841248"/>
+            <a:off x="3909060" y="749808"/>
             <a:ext cx="0" cy="118872"/>
           </a:xfrm>
           <a:prstGeom prst="line">
             <a:avLst/>
           </a:prstGeom>
-          <a:ln w="19050">
+          <a:ln w="15240">
             <a:solidFill>
               <a:srgbClr val="6E7681"/>
             </a:solidFill>
+            <a:headEnd type="triangle" w="med" len="med"/>
             <a:tailEnd type="none"/>
-            <a:headEnd type="triangle" w="med" len="med"/>
           </a:ln>
         </p:spPr>
         <p:style>
@@ -3367,14 +3291,14 @@
       </p:cxnSp>
       <p:sp>
         <p:nvSpPr>
-          <p:cNvPr id="8" name="TextBox 7"/>
+          <p:cNvPr id="6" name="TextBox 5"/>
           <p:cNvSpPr txBox="1"/>
           <p:nvPr/>
         </p:nvSpPr>
         <p:spPr>
           <a:xfrm>
-            <a:off x="6263640" y="822960"/>
-            <a:ext cx="1097280" cy="201168"/>
+            <a:off x="3954780" y="722376"/>
+            <a:ext cx="1371600" cy="182880"/>
           </a:xfrm>
           <a:prstGeom prst="rect">
             <a:avLst/>
@@ -3385,7 +3309,7 @@
           </a:ln>
         </p:spPr>
         <p:txBody>
-          <a:bodyPr wrap="none">
+          <a:bodyPr wrap="square">
             <a:spAutoFit/>
           </a:bodyPr>
           <a:lstStyle/>
@@ -3405,18 +3329,18 @@
       </p:sp>
       <p:sp>
         <p:nvSpPr>
-          <p:cNvPr id="9" name="Rounded Rectangle 8"/>
+          <p:cNvPr id="7" name="Rounded Rectangle 6"/>
           <p:cNvSpPr/>
           <p:nvPr/>
         </p:nvSpPr>
         <p:spPr>
           <a:xfrm>
-            <a:off x="182880" y="960120"/>
-            <a:ext cx="11823192" cy="475488"/>
+            <a:off x="137160" y="868680"/>
+            <a:ext cx="7543800" cy="429768"/>
           </a:xfrm>
           <a:prstGeom prst="roundRect">
             <a:avLst>
-              <a:gd name="adj" fmla="val 15384"/>
+              <a:gd name="adj" fmla="val 8000"/>
             </a:avLst>
           </a:prstGeom>
           <a:solidFill>
@@ -3448,49 +3372,49 @@
           <a:p>
             <a:pPr algn="ctr"/>
             <a:r>
-              <a:rPr b="1" sz="1100">
+              <a:rPr b="1" sz="1000">
                 <a:solidFill>
                   <a:srgbClr val="FFFFFF"/>
                 </a:solidFill>
                 <a:latin typeface="Calibri"/>
               </a:rPr>
-              <a:t>FastAPI API Layer</a:t>
+              <a:t>FastAPI API</a:t>
             </a:r>
           </a:p>
           <a:p>
             <a:pPr algn="ctr"/>
             <a:r>
-              <a:rPr b="0" sz="850">
+              <a:rPr b="0" sz="800">
                 <a:solidFill>
                   <a:srgbClr val="C9D1D9"/>
                 </a:solidFill>
                 <a:latin typeface="Calibri"/>
               </a:rPr>
-              <a:t>/ingest  •  /contracts  •  /sessions  •  /ask/stream  •  /health  •  JWT auth  •  CORS</a:t>
+              <a:t>/ingest  •  /contracts  •  /sessions  •  /ask/stream  •  /health</a:t>
             </a:r>
           </a:p>
         </p:txBody>
       </p:sp>
       <p:cxnSp>
         <p:nvCxnSpPr>
-          <p:cNvPr id="10" name="Connector 9"/>
+          <p:cNvPr id="8" name="Connector 7"/>
           <p:cNvCxnSpPr/>
           <p:nvPr/>
         </p:nvCxnSpPr>
         <p:spPr>
           <a:xfrm>
-            <a:off x="1737360" y="1435608"/>
-            <a:ext cx="0" cy="164592"/>
+            <a:off x="1325880" y="1298448"/>
+            <a:ext cx="0" cy="137160"/>
           </a:xfrm>
           <a:prstGeom prst="line">
             <a:avLst/>
           </a:prstGeom>
-          <a:ln w="19050">
+          <a:ln w="15240">
             <a:solidFill>
               <a:srgbClr val="6E7681"/>
             </a:solidFill>
+            <a:headEnd type="triangle" w="med" len="med"/>
             <a:tailEnd type="none"/>
-            <a:headEnd type="triangle" w="med" len="med"/>
           </a:ln>
         </p:spPr>
         <p:style>
@@ -3510,24 +3434,24 @@
       </p:cxnSp>
       <p:cxnSp>
         <p:nvCxnSpPr>
-          <p:cNvPr id="11" name="Connector 10"/>
+          <p:cNvPr id="9" name="Connector 8"/>
           <p:cNvCxnSpPr/>
           <p:nvPr/>
         </p:nvCxnSpPr>
         <p:spPr>
           <a:xfrm>
-            <a:off x="7955279" y="1435608"/>
-            <a:ext cx="0" cy="164592"/>
+            <a:off x="5440680" y="1298448"/>
+            <a:ext cx="0" cy="137160"/>
           </a:xfrm>
           <a:prstGeom prst="line">
             <a:avLst/>
           </a:prstGeom>
-          <a:ln w="19050">
+          <a:ln w="15240">
             <a:solidFill>
               <a:srgbClr val="6E7681"/>
             </a:solidFill>
+            <a:headEnd type="triangle" w="med" len="med"/>
             <a:tailEnd type="none"/>
-            <a:headEnd type="triangle" w="med" len="med"/>
           </a:ln>
         </p:spPr>
         <p:style>
@@ -3547,18 +3471,18 @@
       </p:cxnSp>
       <p:sp>
         <p:nvSpPr>
-          <p:cNvPr id="12" name="Rounded Rectangle 11"/>
+          <p:cNvPr id="10" name="Rounded Rectangle 9"/>
           <p:cNvSpPr/>
           <p:nvPr/>
         </p:nvSpPr>
         <p:spPr>
           <a:xfrm>
-            <a:off x="182880" y="1600200"/>
-            <a:ext cx="3108960" cy="475488"/>
+            <a:off x="137160" y="1435608"/>
+            <a:ext cx="2560320" cy="429768"/>
           </a:xfrm>
           <a:prstGeom prst="roundRect">
             <a:avLst>
-              <a:gd name="adj" fmla="val 15384"/>
+              <a:gd name="adj" fmla="val 8000"/>
             </a:avLst>
           </a:prstGeom>
           <a:solidFill>
@@ -3590,7 +3514,7 @@
           <a:p>
             <a:pPr algn="ctr"/>
             <a:r>
-              <a:rPr b="1" sz="1000">
+              <a:rPr b="1" sz="950">
                 <a:solidFill>
                   <a:srgbClr val="FFFFFF"/>
                 </a:solidFill>
@@ -3602,31 +3526,31 @@
           <a:p>
             <a:pPr algn="ctr"/>
             <a:r>
-              <a:rPr b="0" sz="800">
+              <a:rPr b="0" sz="750">
                 <a:solidFill>
                   <a:srgbClr val="C9D1D9"/>
                 </a:solidFill>
                 <a:latin typeface="Calibri"/>
               </a:rPr>
-              <a:t>worker.py  •  async job processor  •  status tracking</a:t>
-            </a:r>
-          </a:p>
-        </p:txBody>
-      </p:sp>
-      <p:sp>
-        <p:nvSpPr>
-          <p:cNvPr id="13" name="Rounded Rectangle 12"/>
+              <a:t>worker.py  •  job state tracking</a:t>
+            </a:r>
+          </a:p>
+        </p:txBody>
+      </p:sp>
+      <p:sp>
+        <p:nvSpPr>
+          <p:cNvPr id="11" name="Rounded Rectangle 10"/>
           <p:cNvSpPr/>
           <p:nvPr/>
         </p:nvSpPr>
         <p:spPr>
           <a:xfrm>
-            <a:off x="5669280" y="1600200"/>
-            <a:ext cx="4572000" cy="475488"/>
+            <a:off x="4206240" y="1435608"/>
+            <a:ext cx="3474720" cy="429768"/>
           </a:xfrm>
           <a:prstGeom prst="roundRect">
             <a:avLst>
-              <a:gd name="adj" fmla="val 15384"/>
+              <a:gd name="adj" fmla="val 8000"/>
             </a:avLst>
           </a:prstGeom>
           <a:solidFill>
@@ -3658,7 +3582,7 @@
           <a:p>
             <a:pPr algn="ctr"/>
             <a:r>
-              <a:rPr b="1" sz="1000">
+              <a:rPr b="1" sz="950">
                 <a:solidFill>
                   <a:srgbClr val="FFFFFF"/>
                 </a:solidFill>
@@ -3670,37 +3594,37 @@
           <a:p>
             <a:pPr algn="ctr"/>
             <a:r>
-              <a:rPr b="0" sz="800">
+              <a:rPr b="0" sz="750">
                 <a:solidFill>
                   <a:srgbClr val="C9D1D9"/>
                 </a:solidFill>
                 <a:latin typeface="Calibri"/>
               </a:rPr>
-              <a:t>query_service.py  •  session CRUD  •  contract scoping</a:t>
+              <a:t>query_service.py  •  scoping</a:t>
             </a:r>
           </a:p>
         </p:txBody>
       </p:sp>
       <p:cxnSp>
         <p:nvCxnSpPr>
-          <p:cNvPr id="14" name="Connector 13"/>
+          <p:cNvPr id="12" name="Connector 11"/>
           <p:cNvCxnSpPr/>
           <p:nvPr/>
         </p:nvCxnSpPr>
         <p:spPr>
           <a:xfrm>
-            <a:off x="7955279" y="2075688"/>
-            <a:ext cx="0" cy="164592"/>
+            <a:off x="5440680" y="1865376"/>
+            <a:ext cx="0" cy="118872"/>
           </a:xfrm>
           <a:prstGeom prst="line">
             <a:avLst/>
           </a:prstGeom>
-          <a:ln w="19050">
+          <a:ln w="15240">
             <a:solidFill>
               <a:srgbClr val="6E7681"/>
             </a:solidFill>
+            <a:headEnd type="triangle" w="med" len="med"/>
             <a:tailEnd type="none"/>
-            <a:headEnd type="triangle" w="med" len="med"/>
           </a:ln>
         </p:spPr>
         <p:style>
@@ -3720,26 +3644,26 @@
       </p:cxnSp>
       <p:sp>
         <p:nvSpPr>
-          <p:cNvPr id="15" name="Rounded Rectangle 14"/>
+          <p:cNvPr id="13" name="Rounded Rectangle 12"/>
           <p:cNvSpPr/>
           <p:nvPr/>
         </p:nvSpPr>
         <p:spPr>
           <a:xfrm>
-            <a:off x="5669280" y="2240280"/>
-            <a:ext cx="4572000" cy="530352"/>
+            <a:off x="4206240" y="1984248"/>
+            <a:ext cx="3474720" cy="457200"/>
           </a:xfrm>
           <a:prstGeom prst="roundRect">
             <a:avLst>
-              <a:gd name="adj" fmla="val 13793"/>
+              <a:gd name="adj" fmla="val 8000"/>
             </a:avLst>
           </a:prstGeom>
           <a:solidFill>
-            <a:srgbClr val="B45309"/>
+            <a:srgbClr val="92400E"/>
           </a:solidFill>
           <a:ln w="6350">
             <a:solidFill>
-              <a:srgbClr val="30363D"/>
+              <a:srgbClr val="B45309"/>
             </a:solidFill>
           </a:ln>
         </p:spPr>
@@ -3763,7 +3687,7 @@
           <a:p>
             <a:pPr algn="ctr"/>
             <a:r>
-              <a:rPr b="1" sz="1000">
+              <a:rPr b="1" sz="950">
                 <a:solidFill>
                   <a:srgbClr val="FFFFFF"/>
                 </a:solidFill>
@@ -3775,37 +3699,37 @@
           <a:p>
             <a:pPr algn="ctr"/>
             <a:r>
-              <a:rPr b="0" sz="800">
+              <a:rPr b="0" sz="750">
                 <a:solidFill>
                   <a:srgbClr val="C9D1D9"/>
                 </a:solidFill>
                 <a:latin typeface="Calibri"/>
               </a:rPr>
-              <a:t>Chat sessions  •  Messages  •  Ingestion jobs  •  Contract metadata</a:t>
+              <a:t>Sessions  •  Messages  •  Ingestion jobs</a:t>
             </a:r>
           </a:p>
         </p:txBody>
       </p:sp>
       <p:cxnSp>
         <p:nvCxnSpPr>
-          <p:cNvPr id="16" name="Connector 15"/>
+          <p:cNvPr id="14" name="Connector 13"/>
           <p:cNvCxnSpPr/>
           <p:nvPr/>
         </p:nvCxnSpPr>
         <p:spPr>
           <a:xfrm>
-            <a:off x="1737360" y="2075688"/>
-            <a:ext cx="0" cy="850392"/>
+            <a:off x="1325880" y="1865376"/>
+            <a:ext cx="0" cy="740664"/>
           </a:xfrm>
           <a:prstGeom prst="line">
             <a:avLst/>
           </a:prstGeom>
-          <a:ln w="19050">
+          <a:ln w="15240">
             <a:solidFill>
               <a:srgbClr val="6E7681"/>
             </a:solidFill>
+            <a:headEnd type="triangle" w="med" len="med"/>
             <a:tailEnd type="none"/>
-            <a:headEnd type="triangle" w="med" len="med"/>
           </a:ln>
         </p:spPr>
         <p:style>
@@ -3825,24 +3749,24 @@
       </p:cxnSp>
       <p:cxnSp>
         <p:nvCxnSpPr>
-          <p:cNvPr id="17" name="Connector 16"/>
+          <p:cNvPr id="15" name="Connector 14"/>
           <p:cNvCxnSpPr/>
           <p:nvPr/>
         </p:nvCxnSpPr>
         <p:spPr>
           <a:xfrm>
-            <a:off x="7955279" y="2770632"/>
-            <a:ext cx="0" cy="155448"/>
+            <a:off x="5440680" y="2441448"/>
+            <a:ext cx="0" cy="164592"/>
           </a:xfrm>
           <a:prstGeom prst="line">
             <a:avLst/>
           </a:prstGeom>
-          <a:ln w="19050">
+          <a:ln w="15240">
             <a:solidFill>
               <a:srgbClr val="6E7681"/>
             </a:solidFill>
+            <a:headEnd type="triangle" w="med" len="med"/>
             <a:tailEnd type="none"/>
-            <a:headEnd type="triangle" w="med" len="med"/>
           </a:ln>
         </p:spPr>
         <p:style>
@@ -3862,26 +3786,26 @@
       </p:cxnSp>
       <p:sp>
         <p:nvSpPr>
-          <p:cNvPr id="18" name="Rounded Rectangle 17"/>
+          <p:cNvPr id="16" name="Rounded Rectangle 15"/>
           <p:cNvSpPr/>
           <p:nvPr/>
         </p:nvSpPr>
         <p:spPr>
           <a:xfrm>
-            <a:off x="182880" y="2926080"/>
-            <a:ext cx="5074920" cy="868680"/>
+            <a:off x="137160" y="2606040"/>
+            <a:ext cx="7543800" cy="685800"/>
           </a:xfrm>
           <a:prstGeom prst="roundRect">
             <a:avLst>
-              <a:gd name="adj" fmla="val 8421"/>
+              <a:gd name="adj" fmla="val 8000"/>
             </a:avLst>
           </a:prstGeom>
           <a:solidFill>
-            <a:srgbClr val="238636"/>
+            <a:srgbClr val="1A7F37"/>
           </a:solidFill>
           <a:ln w="6350">
             <a:solidFill>
-              <a:srgbClr val="30363D"/>
+              <a:srgbClr val="238636"/>
             </a:solidFill>
           </a:ln>
         </p:spPr>
@@ -3923,37 +3847,62 @@
                 </a:solidFill>
                 <a:latin typeface="Calibri"/>
               </a:rPr>
-              <a:t>PDF Parse (Doc Intelligence)  →  Clause Tree  →  Chunk  →  Batch Embed (text-embedding-3-large)</a:t>
-            </a:r>
-          </a:p>
-          <a:p>
-            <a:pPr algn="ctr"/>
-            <a:r>
-              <a:rPr b="0" sz="750">
-                <a:solidFill>
-                  <a:srgbClr val="C9D1D9"/>
-                </a:solidFill>
-                <a:latin typeface="Calibri"/>
-              </a:rPr>
-              <a:t>→  Summary (GPT-4o)  →  Search Index  →  KG Extract  →  Entity Resolve  →  Graph Write</a:t>
-            </a:r>
-          </a:p>
-        </p:txBody>
-      </p:sp>
-      <p:sp>
-        <p:nvSpPr>
-          <p:cNvPr id="19" name="Rounded Rectangle 18"/>
+              <a:t>Doc Intelligence  →  Clause Tree  →  Chunk  →  Embed  →  Summary  →  Search Index  →  KG Extract  →  Resolve  →  Graph Write</a:t>
+            </a:r>
+          </a:p>
+        </p:txBody>
+      </p:sp>
+      <p:cxnSp>
+        <p:nvCxnSpPr>
+          <p:cNvPr id="17" name="Connector 16"/>
+          <p:cNvCxnSpPr/>
+          <p:nvPr/>
+        </p:nvCxnSpPr>
+        <p:spPr>
+          <a:xfrm>
+            <a:off x="5440680" y="3291840"/>
+            <a:ext cx="0" cy="118872"/>
+          </a:xfrm>
+          <a:prstGeom prst="line">
+            <a:avLst/>
+          </a:prstGeom>
+          <a:ln w="15240">
+            <a:solidFill>
+              <a:srgbClr val="6E7681"/>
+            </a:solidFill>
+            <a:headEnd type="triangle" w="med" len="med"/>
+            <a:tailEnd type="none"/>
+          </a:ln>
+        </p:spPr>
+        <p:style>
+          <a:lnRef idx="2">
+            <a:schemeClr val="accent1"/>
+          </a:lnRef>
+          <a:fillRef idx="0">
+            <a:schemeClr val="accent1"/>
+          </a:fillRef>
+          <a:effectRef idx="1">
+            <a:schemeClr val="accent1"/>
+          </a:effectRef>
+          <a:fontRef idx="minor">
+            <a:schemeClr val="tx1"/>
+          </a:fontRef>
+        </p:style>
+      </p:cxnSp>
+      <p:sp>
+        <p:nvSpPr>
+          <p:cNvPr id="18" name="Rounded Rectangle 17"/>
           <p:cNvSpPr/>
           <p:nvPr/>
         </p:nvSpPr>
         <p:spPr>
           <a:xfrm>
-            <a:off x="5669280" y="2926080"/>
-            <a:ext cx="6336792" cy="566928"/>
+            <a:off x="3794760" y="3410712"/>
+            <a:ext cx="3886200" cy="429768"/>
           </a:xfrm>
           <a:prstGeom prst="roundRect">
             <a:avLst>
-              <a:gd name="adj" fmla="val 12903"/>
+              <a:gd name="adj" fmla="val 8000"/>
             </a:avLst>
           </a:prstGeom>
           <a:solidFill>
@@ -3961,7 +3910,7 @@
           </a:solidFill>
           <a:ln w="6350">
             <a:solidFill>
-              <a:srgbClr val="30363D"/>
+              <a:srgbClr val="8957E5"/>
             </a:solidFill>
           </a:ln>
         </p:spPr>
@@ -3985,7 +3934,7 @@
           <a:p>
             <a:pPr algn="ctr"/>
             <a:r>
-              <a:rPr b="1" sz="1000">
+              <a:rPr b="1" sz="950">
                 <a:solidFill>
                   <a:srgbClr val="FFFFFF"/>
                 </a:solidFill>
@@ -3997,17 +3946,54 @@
           <a:p>
             <a:pPr algn="ctr"/>
             <a:r>
-              <a:rPr b="0" sz="800">
+              <a:rPr b="0" sz="750">
                 <a:solidFill>
                   <a:srgbClr val="C9D1D9"/>
                 </a:solidFill>
                 <a:latin typeface="Calibri"/>
               </a:rPr>
-              <a:t>LLM classifier  •  scope resolution  •  summary shortcut  •  hybrid / graph / compare</a:t>
-            </a:r>
-          </a:p>
-        </p:txBody>
-      </p:sp>
+              <a:t>LLM classifier  •  scope resolution  •  comparison detection</a:t>
+            </a:r>
+          </a:p>
+        </p:txBody>
+      </p:sp>
+      <p:cxnSp>
+        <p:nvCxnSpPr>
+          <p:cNvPr id="19" name="Connector 18"/>
+          <p:cNvCxnSpPr/>
+          <p:nvPr/>
+        </p:nvCxnSpPr>
+        <p:spPr>
+          <a:xfrm>
+            <a:off x="960120" y="3291840"/>
+            <a:ext cx="0" cy="2697480"/>
+          </a:xfrm>
+          <a:prstGeom prst="line">
+            <a:avLst/>
+          </a:prstGeom>
+          <a:ln w="15240">
+            <a:solidFill>
+              <a:srgbClr val="6E7681"/>
+            </a:solidFill>
+            <a:headEnd type="triangle" w="med" len="med"/>
+            <a:tailEnd type="none"/>
+          </a:ln>
+        </p:spPr>
+        <p:style>
+          <a:lnRef idx="2">
+            <a:schemeClr val="accent1"/>
+          </a:lnRef>
+          <a:fillRef idx="0">
+            <a:schemeClr val="accent1"/>
+          </a:fillRef>
+          <a:effectRef idx="1">
+            <a:schemeClr val="accent1"/>
+          </a:effectRef>
+          <a:fontRef idx="minor">
+            <a:schemeClr val="tx1"/>
+          </a:fontRef>
+        </p:style>
+      </p:cxnSp>
       <p:cxnSp>
         <p:nvCxnSpPr>
           <p:cNvPr id="20" name="Connector 19"/>
@@ -4016,18 +4002,18 @@
         </p:nvCxnSpPr>
         <p:spPr>
           <a:xfrm>
-            <a:off x="6858000" y="3493008"/>
-            <a:ext cx="0" cy="137160"/>
+            <a:off x="2468879" y="3291840"/>
+            <a:ext cx="0" cy="2697480"/>
           </a:xfrm>
           <a:prstGeom prst="line">
             <a:avLst/>
           </a:prstGeom>
-          <a:ln w="19050">
+          <a:ln w="15240">
             <a:solidFill>
               <a:srgbClr val="6E7681"/>
             </a:solidFill>
+            <a:headEnd type="triangle" w="med" len="med"/>
             <a:tailEnd type="none"/>
-            <a:headEnd type="triangle" w="med" len="med"/>
           </a:ln>
         </p:spPr>
         <p:style>
@@ -4053,18 +4039,18 @@
         </p:nvCxnSpPr>
         <p:spPr>
           <a:xfrm>
-            <a:off x="10332720" y="3493008"/>
-            <a:ext cx="0" cy="137160"/>
+            <a:off x="3886200" y="3291840"/>
+            <a:ext cx="0" cy="2697480"/>
           </a:xfrm>
           <a:prstGeom prst="line">
             <a:avLst/>
           </a:prstGeom>
-          <a:ln w="19050">
+          <a:ln w="15240">
             <a:solidFill>
               <a:srgbClr val="6E7681"/>
             </a:solidFill>
+            <a:headEnd type="triangle" w="med" len="med"/>
             <a:tailEnd type="none"/>
-            <a:headEnd type="triangle" w="med" len="med"/>
           </a:ln>
         </p:spPr>
         <p:style>
@@ -4090,8 +4076,82 @@
         </p:nvCxnSpPr>
         <p:spPr>
           <a:xfrm>
-            <a:off x="6858000" y="3566160"/>
-            <a:ext cx="3474720" cy="0"/>
+            <a:off x="4709160" y="3840480"/>
+            <a:ext cx="0" cy="118872"/>
+          </a:xfrm>
+          <a:prstGeom prst="line">
+            <a:avLst/>
+          </a:prstGeom>
+          <a:ln w="15240">
+            <a:solidFill>
+              <a:srgbClr val="6E7681"/>
+            </a:solidFill>
+            <a:headEnd type="triangle" w="med" len="med"/>
+            <a:tailEnd type="none"/>
+          </a:ln>
+        </p:spPr>
+        <p:style>
+          <a:lnRef idx="2">
+            <a:schemeClr val="accent1"/>
+          </a:lnRef>
+          <a:fillRef idx="0">
+            <a:schemeClr val="accent1"/>
+          </a:fillRef>
+          <a:effectRef idx="1">
+            <a:schemeClr val="accent1"/>
+          </a:effectRef>
+          <a:fontRef idx="minor">
+            <a:schemeClr val="tx1"/>
+          </a:fontRef>
+        </p:style>
+      </p:cxnSp>
+      <p:cxnSp>
+        <p:nvCxnSpPr>
+          <p:cNvPr id="23" name="Connector 22"/>
+          <p:cNvCxnSpPr/>
+          <p:nvPr/>
+        </p:nvCxnSpPr>
+        <p:spPr>
+          <a:xfrm>
+            <a:off x="6720840" y="3840480"/>
+            <a:ext cx="0" cy="118872"/>
+          </a:xfrm>
+          <a:prstGeom prst="line">
+            <a:avLst/>
+          </a:prstGeom>
+          <a:ln w="15240">
+            <a:solidFill>
+              <a:srgbClr val="6E7681"/>
+            </a:solidFill>
+            <a:headEnd type="triangle" w="med" len="med"/>
+            <a:tailEnd type="none"/>
+          </a:ln>
+        </p:spPr>
+        <p:style>
+          <a:lnRef idx="2">
+            <a:schemeClr val="accent1"/>
+          </a:lnRef>
+          <a:fillRef idx="0">
+            <a:schemeClr val="accent1"/>
+          </a:fillRef>
+          <a:effectRef idx="1">
+            <a:schemeClr val="accent1"/>
+          </a:effectRef>
+          <a:fontRef idx="minor">
+            <a:schemeClr val="tx1"/>
+          </a:fontRef>
+        </p:style>
+      </p:cxnSp>
+      <p:cxnSp>
+        <p:nvCxnSpPr>
+          <p:cNvPr id="24" name="Connector 23"/>
+          <p:cNvCxnSpPr/>
+          <p:nvPr/>
+        </p:nvCxnSpPr>
+        <p:spPr>
+          <a:xfrm>
+            <a:off x="4709160" y="3895344"/>
+            <a:ext cx="2011680" cy="0"/>
           </a:xfrm>
           <a:prstGeom prst="line">
             <a:avLst/>
@@ -4119,18 +4179,18 @@
       </p:cxnSp>
       <p:sp>
         <p:nvSpPr>
-          <p:cNvPr id="23" name="Rounded Rectangle 22"/>
+          <p:cNvPr id="25" name="Rounded Rectangle 24"/>
           <p:cNvSpPr/>
           <p:nvPr/>
         </p:nvSpPr>
         <p:spPr>
           <a:xfrm>
-            <a:off x="5669280" y="3630168"/>
-            <a:ext cx="2743200" cy="749808"/>
+            <a:off x="3657600" y="3959352"/>
+            <a:ext cx="1737360" cy="658368"/>
           </a:xfrm>
           <a:prstGeom prst="roundRect">
             <a:avLst>
-              <a:gd name="adj" fmla="val 9756"/>
+              <a:gd name="adj" fmla="val 8000"/>
             </a:avLst>
           </a:prstGeom>
           <a:solidFill>
@@ -4162,7 +4222,7 @@
           <a:p>
             <a:pPr algn="ctr"/>
             <a:r>
-              <a:rPr b="1" sz="950">
+              <a:rPr b="1" sz="900">
                 <a:solidFill>
                   <a:srgbClr val="FFFFFF"/>
                 </a:solidFill>
@@ -4180,37 +4240,26 @@
                 </a:solidFill>
                 <a:latin typeface="Calibri"/>
               </a:rPr>
-              <a:t>SemanticRetriever  •  Azure Search</a:t>
-            </a:r>
-          </a:p>
-          <a:p>
-            <a:pPr algn="ctr"/>
-            <a:r>
-              <a:rPr b="0" sz="750">
-                <a:solidFill>
-                  <a:srgbClr val="C9D1D9"/>
-                </a:solidFill>
-                <a:latin typeface="Calibri"/>
-              </a:rPr>
-              <a:t>BM25 + vector  •  parent/child expansion</a:t>
-            </a:r>
-          </a:p>
-        </p:txBody>
-      </p:sp>
-      <p:sp>
-        <p:nvSpPr>
-          <p:cNvPr id="24" name="Rounded Rectangle 23"/>
+              <a:t>Azure Search
+BM25 + vector</a:t>
+            </a:r>
+          </a:p>
+        </p:txBody>
+      </p:sp>
+      <p:sp>
+        <p:nvSpPr>
+          <p:cNvPr id="26" name="Rounded Rectangle 25"/>
           <p:cNvSpPr/>
           <p:nvPr/>
         </p:nvSpPr>
         <p:spPr>
           <a:xfrm>
-            <a:off x="8732520" y="3630168"/>
-            <a:ext cx="3273552" cy="749808"/>
+            <a:off x="5715000" y="3959352"/>
+            <a:ext cx="1920240" cy="658368"/>
           </a:xfrm>
           <a:prstGeom prst="roundRect">
             <a:avLst>
-              <a:gd name="adj" fmla="val 9756"/>
+              <a:gd name="adj" fmla="val 8000"/>
             </a:avLst>
           </a:prstGeom>
           <a:solidFill>
@@ -4242,7 +4291,7 @@
           <a:p>
             <a:pPr algn="ctr"/>
             <a:r>
-              <a:rPr b="1" sz="950">
+              <a:rPr b="1" sz="900">
                 <a:solidFill>
                   <a:srgbClr val="FFFFFF"/>
                 </a:solidFill>
@@ -4260,43 +4309,32 @@
                 </a:solidFill>
                 <a:latin typeface="Calibri"/>
               </a:rPr>
-              <a:t>Entity linking → RESOLVED_AS</a:t>
-            </a:r>
-          </a:p>
-          <a:p>
-            <a:pPr algn="ctr"/>
-            <a:r>
-              <a:rPr b="0" sz="750">
-                <a:solidFill>
-                  <a:srgbClr val="C9D1D9"/>
-                </a:solidFill>
-                <a:latin typeface="Calibri"/>
-              </a:rPr>
-              <a:t>Gremlin traversal  •  vector fallback</a:t>
+              <a:t>Gremlin KG
+entity linking</a:t>
             </a:r>
           </a:p>
         </p:txBody>
       </p:sp>
       <p:cxnSp>
         <p:nvCxnSpPr>
-          <p:cNvPr id="25" name="Connector 24"/>
+          <p:cNvPr id="27" name="Connector 26"/>
           <p:cNvCxnSpPr/>
           <p:nvPr/>
         </p:nvCxnSpPr>
         <p:spPr>
           <a:xfrm>
-            <a:off x="7040880" y="4379976"/>
-            <a:ext cx="0" cy="164592"/>
+            <a:off x="4709160" y="4617720"/>
+            <a:ext cx="0" cy="118872"/>
           </a:xfrm>
           <a:prstGeom prst="line">
             <a:avLst/>
           </a:prstGeom>
-          <a:ln w="19050">
+          <a:ln w="15240">
             <a:solidFill>
               <a:srgbClr val="6E7681"/>
             </a:solidFill>
+            <a:headEnd type="triangle" w="med" len="med"/>
             <a:tailEnd type="none"/>
-            <a:headEnd type="triangle" w="med" len="med"/>
           </a:ln>
         </p:spPr>
         <p:style>
@@ -4316,24 +4354,24 @@
       </p:cxnSp>
       <p:cxnSp>
         <p:nvCxnSpPr>
-          <p:cNvPr id="26" name="Connector 25"/>
+          <p:cNvPr id="28" name="Connector 27"/>
           <p:cNvCxnSpPr/>
           <p:nvPr/>
         </p:nvCxnSpPr>
         <p:spPr>
           <a:xfrm>
-            <a:off x="10369296" y="4379976"/>
-            <a:ext cx="0" cy="164592"/>
+            <a:off x="6720840" y="4617720"/>
+            <a:ext cx="0" cy="118872"/>
           </a:xfrm>
           <a:prstGeom prst="line">
             <a:avLst/>
           </a:prstGeom>
-          <a:ln w="19050">
+          <a:ln w="15240">
             <a:solidFill>
               <a:srgbClr val="6E7681"/>
             </a:solidFill>
+            <a:headEnd type="triangle" w="med" len="med"/>
             <a:tailEnd type="none"/>
-            <a:headEnd type="triangle" w="med" len="med"/>
           </a:ln>
         </p:spPr>
         <p:style>
@@ -4353,14 +4391,14 @@
       </p:cxnSp>
       <p:cxnSp>
         <p:nvCxnSpPr>
-          <p:cNvPr id="27" name="Connector 26"/>
+          <p:cNvPr id="29" name="Connector 28"/>
           <p:cNvCxnSpPr/>
           <p:nvPr/>
         </p:nvCxnSpPr>
         <p:spPr>
           <a:xfrm>
-            <a:off x="7040880" y="4480560"/>
-            <a:ext cx="3328416" cy="0"/>
+            <a:off x="4709160" y="4681728"/>
+            <a:ext cx="2011680" cy="0"/>
           </a:xfrm>
           <a:prstGeom prst="line">
             <a:avLst/>
@@ -4388,18 +4426,18 @@
       </p:cxnSp>
       <p:sp>
         <p:nvSpPr>
-          <p:cNvPr id="28" name="Rounded Rectangle 27"/>
+          <p:cNvPr id="30" name="Rounded Rectangle 29"/>
           <p:cNvSpPr/>
           <p:nvPr/>
         </p:nvSpPr>
         <p:spPr>
           <a:xfrm>
-            <a:off x="5669280" y="4544568"/>
-            <a:ext cx="6336792" cy="566928"/>
+            <a:off x="3657600" y="4736592"/>
+            <a:ext cx="3977639" cy="429768"/>
           </a:xfrm>
           <a:prstGeom prst="roundRect">
             <a:avLst>
-              <a:gd name="adj" fmla="val 12903"/>
+              <a:gd name="adj" fmla="val 8000"/>
             </a:avLst>
           </a:prstGeom>
           <a:solidFill>
@@ -4407,7 +4445,7 @@
           </a:solidFill>
           <a:ln w="6350">
             <a:solidFill>
-              <a:srgbClr val="30363D"/>
+              <a:srgbClr val="8957E5"/>
             </a:solidFill>
           </a:ln>
         </p:spPr>
@@ -4431,7 +4469,7 @@
           <a:p>
             <a:pPr algn="ctr"/>
             <a:r>
-              <a:rPr b="1" sz="1000">
+              <a:rPr b="1" sz="950">
                 <a:solidFill>
                   <a:srgbClr val="FFFFFF"/>
                 </a:solidFill>
@@ -4443,37 +4481,37 @@
           <a:p>
             <a:pPr algn="ctr"/>
             <a:r>
-              <a:rPr b="0" sz="800">
+              <a:rPr b="0" sz="750">
                 <a:solidFill>
                   <a:srgbClr val="C9D1D9"/>
                 </a:solidFill>
                 <a:latin typeface="Calibri"/>
               </a:rPr>
-              <a:t>Both routes merged  •  CONTRACT A / B side-by-side when 2+ contracts scoped</a:t>
+              <a:t>CONTRACT A / B side-by-side  •  grounded context</a:t>
             </a:r>
           </a:p>
         </p:txBody>
       </p:sp>
       <p:cxnSp>
         <p:nvCxnSpPr>
-          <p:cNvPr id="29" name="Connector 28"/>
+          <p:cNvPr id="31" name="Connector 30"/>
           <p:cNvCxnSpPr/>
           <p:nvPr/>
         </p:nvCxnSpPr>
         <p:spPr>
           <a:xfrm>
-            <a:off x="8837676" y="5111496"/>
-            <a:ext cx="0" cy="146304"/>
+            <a:off x="5646420" y="5166360"/>
+            <a:ext cx="0" cy="118872"/>
           </a:xfrm>
           <a:prstGeom prst="line">
             <a:avLst/>
           </a:prstGeom>
-          <a:ln w="19050">
+          <a:ln w="15240">
             <a:solidFill>
               <a:srgbClr val="6E7681"/>
             </a:solidFill>
+            <a:headEnd type="triangle" w="med" len="med"/>
             <a:tailEnd type="none"/>
-            <a:headEnd type="triangle" w="med" len="med"/>
           </a:ln>
         </p:spPr>
         <p:style>
@@ -4493,18 +4531,18 @@
       </p:cxnSp>
       <p:sp>
         <p:nvSpPr>
-          <p:cNvPr id="30" name="Rounded Rectangle 29"/>
+          <p:cNvPr id="32" name="Rounded Rectangle 31"/>
           <p:cNvSpPr/>
           <p:nvPr/>
         </p:nvSpPr>
         <p:spPr>
           <a:xfrm>
-            <a:off x="5669280" y="5257800"/>
-            <a:ext cx="6336792" cy="566928"/>
+            <a:off x="3657600" y="5285232"/>
+            <a:ext cx="3977639" cy="502920"/>
           </a:xfrm>
           <a:prstGeom prst="roundRect">
             <a:avLst>
-              <a:gd name="adj" fmla="val 12903"/>
+              <a:gd name="adj" fmla="val 8000"/>
             </a:avLst>
           </a:prstGeom>
           <a:solidFill>
@@ -4512,7 +4550,7 @@
           </a:solidFill>
           <a:ln w="6350">
             <a:solidFill>
-              <a:srgbClr val="30363D"/>
+              <a:srgbClr val="8957E5"/>
             </a:solidFill>
           </a:ln>
         </p:spPr>
@@ -4536,230 +4574,45 @@
           <a:p>
             <a:pPr algn="ctr"/>
             <a:r>
-              <a:rPr b="1" sz="1000">
+              <a:rPr b="1" sz="950">
                 <a:solidFill>
                   <a:srgbClr val="FFFFFF"/>
                 </a:solidFill>
                 <a:latin typeface="Calibri"/>
               </a:rPr>
-              <a:t>Answer Generation</a:t>
+              <a:t>Answer Generation + Grounding</a:t>
             </a:r>
           </a:p>
           <a:p>
             <a:pPr algn="ctr"/>
             <a:r>
-              <a:rPr b="0" sz="800">
+              <a:rPr b="0" sz="750">
                 <a:solidFill>
                   <a:srgbClr val="C9D1D9"/>
                 </a:solidFill>
                 <a:latin typeface="Calibri"/>
               </a:rPr>
-              <a:t>GPT-4o  •  [S#] grounding  •  citations  •  SSE streaming back to UI</a:t>
-            </a:r>
-          </a:p>
-        </p:txBody>
-      </p:sp>
-      <p:cxnSp>
-        <p:nvCxnSpPr>
-          <p:cNvPr id="31" name="Connector 30"/>
-          <p:cNvCxnSpPr/>
-          <p:nvPr/>
-        </p:nvCxnSpPr>
-        <p:spPr>
-          <a:xfrm>
-            <a:off x="1005840" y="3794760"/>
-            <a:ext cx="0" cy="2103120"/>
-          </a:xfrm>
-          <a:prstGeom prst="line">
-            <a:avLst/>
-          </a:prstGeom>
-          <a:ln w="19050">
-            <a:solidFill>
-              <a:srgbClr val="6E7681"/>
-            </a:solidFill>
-            <a:tailEnd type="none"/>
-            <a:headEnd type="triangle" w="med" len="med"/>
-          </a:ln>
-        </p:spPr>
-        <p:style>
-          <a:lnRef idx="2">
-            <a:schemeClr val="accent1"/>
-          </a:lnRef>
-          <a:fillRef idx="0">
-            <a:schemeClr val="accent1"/>
-          </a:fillRef>
-          <a:effectRef idx="1">
-            <a:schemeClr val="accent1"/>
-          </a:effectRef>
-          <a:fontRef idx="minor">
-            <a:schemeClr val="tx1"/>
-          </a:fontRef>
-        </p:style>
-      </p:cxnSp>
-      <p:cxnSp>
-        <p:nvCxnSpPr>
-          <p:cNvPr id="32" name="Connector 31"/>
-          <p:cNvCxnSpPr/>
-          <p:nvPr/>
-        </p:nvCxnSpPr>
-        <p:spPr>
-          <a:xfrm>
-            <a:off x="2743200" y="3794760"/>
-            <a:ext cx="0" cy="2103120"/>
-          </a:xfrm>
-          <a:prstGeom prst="line">
-            <a:avLst/>
-          </a:prstGeom>
-          <a:ln w="19050">
-            <a:solidFill>
-              <a:srgbClr val="6E7681"/>
-            </a:solidFill>
-            <a:tailEnd type="none"/>
-            <a:headEnd type="triangle" w="med" len="med"/>
-          </a:ln>
-        </p:spPr>
-        <p:style>
-          <a:lnRef idx="2">
-            <a:schemeClr val="accent1"/>
-          </a:lnRef>
-          <a:fillRef idx="0">
-            <a:schemeClr val="accent1"/>
-          </a:fillRef>
-          <a:effectRef idx="1">
-            <a:schemeClr val="accent1"/>
-          </a:effectRef>
-          <a:fontRef idx="minor">
-            <a:schemeClr val="tx1"/>
-          </a:fontRef>
-        </p:style>
-      </p:cxnSp>
-      <p:cxnSp>
-        <p:nvCxnSpPr>
-          <p:cNvPr id="33" name="Connector 32"/>
-          <p:cNvCxnSpPr/>
-          <p:nvPr/>
-        </p:nvCxnSpPr>
-        <p:spPr>
-          <a:xfrm>
-            <a:off x="4389120" y="3794760"/>
-            <a:ext cx="0" cy="2103120"/>
-          </a:xfrm>
-          <a:prstGeom prst="line">
-            <a:avLst/>
-          </a:prstGeom>
-          <a:ln w="19050">
-            <a:solidFill>
-              <a:srgbClr val="6E7681"/>
-            </a:solidFill>
-            <a:tailEnd type="none"/>
-            <a:headEnd type="triangle" w="med" len="med"/>
-          </a:ln>
-        </p:spPr>
-        <p:style>
-          <a:lnRef idx="2">
-            <a:schemeClr val="accent1"/>
-          </a:lnRef>
-          <a:fillRef idx="0">
-            <a:schemeClr val="accent1"/>
-          </a:fillRef>
-          <a:effectRef idx="1">
-            <a:schemeClr val="accent1"/>
-          </a:effectRef>
-          <a:fontRef idx="minor">
-            <a:schemeClr val="tx1"/>
-          </a:fontRef>
-        </p:style>
-      </p:cxnSp>
-      <p:cxnSp>
-        <p:nvCxnSpPr>
-          <p:cNvPr id="34" name="Connector 33"/>
-          <p:cNvCxnSpPr/>
-          <p:nvPr/>
-        </p:nvCxnSpPr>
-        <p:spPr>
-          <a:xfrm flipH="1">
-            <a:off x="2743200" y="4379976"/>
-            <a:ext cx="4297680" cy="1517904"/>
-          </a:xfrm>
-          <a:prstGeom prst="line">
-            <a:avLst/>
-          </a:prstGeom>
-          <a:ln w="19050">
-            <a:solidFill>
-              <a:srgbClr val="6E7681"/>
-            </a:solidFill>
-            <a:tailEnd type="none"/>
-            <a:headEnd type="triangle" w="med" len="med"/>
-          </a:ln>
-        </p:spPr>
-        <p:style>
-          <a:lnRef idx="2">
-            <a:schemeClr val="accent1"/>
-          </a:lnRef>
-          <a:fillRef idx="0">
-            <a:schemeClr val="accent1"/>
-          </a:fillRef>
-          <a:effectRef idx="1">
-            <a:schemeClr val="accent1"/>
-          </a:effectRef>
-          <a:fontRef idx="minor">
-            <a:schemeClr val="tx1"/>
-          </a:fontRef>
-        </p:style>
-      </p:cxnSp>
-      <p:cxnSp>
-        <p:nvCxnSpPr>
-          <p:cNvPr id="35" name="Connector 34"/>
-          <p:cNvCxnSpPr/>
-          <p:nvPr/>
-        </p:nvCxnSpPr>
-        <p:spPr>
-          <a:xfrm flipH="1">
-            <a:off x="4389120" y="4379976"/>
-            <a:ext cx="5980176" cy="1517904"/>
-          </a:xfrm>
-          <a:prstGeom prst="line">
-            <a:avLst/>
-          </a:prstGeom>
-          <a:ln w="19050">
-            <a:solidFill>
-              <a:srgbClr val="6E7681"/>
-            </a:solidFill>
-            <a:tailEnd type="none"/>
-            <a:headEnd type="triangle" w="med" len="med"/>
-          </a:ln>
-        </p:spPr>
-        <p:style>
-          <a:lnRef idx="2">
-            <a:schemeClr val="accent1"/>
-          </a:lnRef>
-          <a:fillRef idx="0">
-            <a:schemeClr val="accent1"/>
-          </a:fillRef>
-          <a:effectRef idx="1">
-            <a:schemeClr val="accent1"/>
-          </a:effectRef>
-          <a:fontRef idx="minor">
-            <a:schemeClr val="tx1"/>
-          </a:fontRef>
-        </p:style>
-      </p:cxnSp>
-      <p:sp>
-        <p:nvSpPr>
-          <p:cNvPr id="36" name="Rectangle 35"/>
+              <a:t>GPT-4o  •  [S#] citations  •  SSE stream to UI</a:t>
+            </a:r>
+          </a:p>
+        </p:txBody>
+      </p:sp>
+      <p:sp>
+        <p:nvSpPr>
+          <p:cNvPr id="33" name="Rectangle 32"/>
           <p:cNvSpPr/>
           <p:nvPr/>
         </p:nvSpPr>
         <p:spPr>
           <a:xfrm>
-            <a:off x="0" y="5870448"/>
-            <a:ext cx="12188952" cy="987552"/>
+            <a:off x="0" y="5916168"/>
+            <a:ext cx="7818120" cy="941832"/>
           </a:xfrm>
           <a:prstGeom prst="rect">
             <a:avLst/>
           </a:prstGeom>
           <a:solidFill>
-            <a:srgbClr val="1A1F2E"/>
+            <a:srgbClr val="161B22"/>
           </a:solidFill>
           <a:ln>
             <a:noFill/>
@@ -4789,14 +4642,14 @@
       </p:sp>
       <p:sp>
         <p:nvSpPr>
-          <p:cNvPr id="37" name="TextBox 36"/>
+          <p:cNvPr id="34" name="TextBox 33"/>
           <p:cNvSpPr txBox="1"/>
           <p:nvPr/>
         </p:nvSpPr>
         <p:spPr>
           <a:xfrm>
-            <a:off x="182880" y="5879592"/>
-            <a:ext cx="2743200" cy="201168"/>
+            <a:off x="164592" y="5916168"/>
+            <a:ext cx="3657600" cy="201168"/>
           </a:xfrm>
           <a:prstGeom prst="rect">
             <a:avLst/>
@@ -4807,46 +4660,46 @@
           </a:ln>
         </p:spPr>
         <p:txBody>
-          <a:bodyPr wrap="none">
+          <a:bodyPr wrap="square">
             <a:spAutoFit/>
           </a:bodyPr>
           <a:lstStyle/>
           <a:p>
             <a:pPr algn="l"/>
             <a:r>
-              <a:rPr b="1" sz="750">
+              <a:rPr b="1" sz="700">
                 <a:solidFill>
                   <a:srgbClr val="E3B341"/>
                 </a:solidFill>
                 <a:latin typeface="Calibri"/>
               </a:rPr>
-              <a:t>AZURE STORAGE &amp; SERVICES LAYER</a:t>
-            </a:r>
-          </a:p>
-        </p:txBody>
-      </p:sp>
-      <p:sp>
-        <p:nvSpPr>
-          <p:cNvPr id="38" name="Rounded Rectangle 37"/>
+              <a:t>AZURE STORAGE &amp; SERVICES</a:t>
+            </a:r>
+          </a:p>
+        </p:txBody>
+      </p:sp>
+      <p:sp>
+        <p:nvSpPr>
+          <p:cNvPr id="35" name="Rounded Rectangle 34"/>
           <p:cNvSpPr/>
           <p:nvPr/>
         </p:nvSpPr>
         <p:spPr>
           <a:xfrm>
-            <a:off x="182880" y="6099048"/>
-            <a:ext cx="2560320" cy="658368"/>
+            <a:off x="164592" y="6126480"/>
+            <a:ext cx="1783080" cy="621792"/>
           </a:xfrm>
           <a:prstGeom prst="roundRect">
             <a:avLst>
-              <a:gd name="adj" fmla="val 11111"/>
+              <a:gd name="adj" fmla="val 8000"/>
             </a:avLst>
           </a:prstGeom>
           <a:solidFill>
-            <a:srgbClr val="B45309"/>
+            <a:srgbClr val="92400E"/>
           </a:solidFill>
           <a:ln w="6350">
             <a:solidFill>
-              <a:srgbClr val="92400E"/>
+              <a:srgbClr val="B45309"/>
             </a:solidFill>
           </a:ln>
         </p:spPr>
@@ -4870,13 +4723,13 @@
           <a:p>
             <a:pPr algn="ctr"/>
             <a:r>
-              <a:rPr b="1" sz="900">
+              <a:rPr b="1" sz="850">
                 <a:solidFill>
                   <a:srgbClr val="FFFFFF"/>
                 </a:solidFill>
                 <a:latin typeface="Calibri"/>
               </a:rPr>
-              <a:t>Azure Blob Storage</a:t>
+              <a:t>Azure Blob</a:t>
             </a:r>
           </a:p>
           <a:p>
@@ -4888,33 +4741,33 @@
                 </a:solidFill>
                 <a:latin typeface="Calibri"/>
               </a:rPr>
-              <a:t>Raw PDFs  •  chunked text  •  processed docs</a:t>
-            </a:r>
-          </a:p>
-        </p:txBody>
-      </p:sp>
-      <p:sp>
-        <p:nvSpPr>
-          <p:cNvPr id="39" name="Rounded Rectangle 38"/>
+              <a:t>PDFs • artifacts</a:t>
+            </a:r>
+          </a:p>
+        </p:txBody>
+      </p:sp>
+      <p:sp>
+        <p:nvSpPr>
+          <p:cNvPr id="36" name="Rounded Rectangle 35"/>
           <p:cNvSpPr/>
           <p:nvPr/>
         </p:nvSpPr>
         <p:spPr>
           <a:xfrm>
-            <a:off x="2926080" y="6099048"/>
-            <a:ext cx="3017520" cy="658368"/>
+            <a:off x="2103120" y="6126480"/>
+            <a:ext cx="1783080" cy="621792"/>
           </a:xfrm>
           <a:prstGeom prst="roundRect">
             <a:avLst>
-              <a:gd name="adj" fmla="val 11111"/>
+              <a:gd name="adj" fmla="val 8000"/>
             </a:avLst>
           </a:prstGeom>
           <a:solidFill>
-            <a:srgbClr val="B45309"/>
+            <a:srgbClr val="92400E"/>
           </a:solidFill>
           <a:ln w="6350">
             <a:solidFill>
-              <a:srgbClr val="92400E"/>
+              <a:srgbClr val="B45309"/>
             </a:solidFill>
           </a:ln>
         </p:spPr>
@@ -4938,7 +4791,7 @@
           <a:p>
             <a:pPr algn="ctr"/>
             <a:r>
-              <a:rPr b="1" sz="900">
+              <a:rPr b="1" sz="850">
                 <a:solidFill>
                   <a:srgbClr val="FFFFFF"/>
                 </a:solidFill>
@@ -4956,33 +4809,33 @@
                 </a:solidFill>
                 <a:latin typeface="Calibri"/>
               </a:rPr>
-              <a:t>BM25 + vector index  •  hybrid retrieval</a:t>
-            </a:r>
-          </a:p>
-        </p:txBody>
-      </p:sp>
-      <p:sp>
-        <p:nvSpPr>
-          <p:cNvPr id="40" name="Rounded Rectangle 39"/>
+              <a:t>BM25 + vector</a:t>
+            </a:r>
+          </a:p>
+        </p:txBody>
+      </p:sp>
+      <p:sp>
+        <p:nvSpPr>
+          <p:cNvPr id="37" name="Rounded Rectangle 36"/>
           <p:cNvSpPr/>
           <p:nvPr/>
         </p:nvSpPr>
         <p:spPr>
           <a:xfrm>
-            <a:off x="6126480" y="6099048"/>
-            <a:ext cx="3017520" cy="658368"/>
+            <a:off x="4069080" y="6126480"/>
+            <a:ext cx="1783080" cy="621792"/>
           </a:xfrm>
           <a:prstGeom prst="roundRect">
             <a:avLst>
-              <a:gd name="adj" fmla="val 11111"/>
+              <a:gd name="adj" fmla="val 8000"/>
             </a:avLst>
           </a:prstGeom>
           <a:solidFill>
-            <a:srgbClr val="B45309"/>
+            <a:srgbClr val="92400E"/>
           </a:solidFill>
           <a:ln w="6350">
             <a:solidFill>
-              <a:srgbClr val="92400E"/>
+              <a:srgbClr val="B45309"/>
             </a:solidFill>
           </a:ln>
         </p:spPr>
@@ -5006,13 +4859,13 @@
           <a:p>
             <a:pPr algn="ctr"/>
             <a:r>
-              <a:rPr b="1" sz="900">
+              <a:rPr b="1" sz="850">
                 <a:solidFill>
                   <a:srgbClr val="FFFFFF"/>
                 </a:solidFill>
                 <a:latin typeface="Calibri"/>
               </a:rPr>
-              <a:t>Cosmos DB  (Gremlin)</a:t>
+              <a:t>Cosmos Gremlin</a:t>
             </a:r>
           </a:p>
           <a:p>
@@ -5024,33 +4877,33 @@
                 </a:solidFill>
                 <a:latin typeface="Calibri"/>
               </a:rPr>
-              <a:t>Knowledge Graph  •  entities  •  relationships</a:t>
-            </a:r>
-          </a:p>
-        </p:txBody>
-      </p:sp>
-      <p:sp>
-        <p:nvSpPr>
-          <p:cNvPr id="41" name="Rounded Rectangle 40"/>
+              <a:t>Knowledge Graph</a:t>
+            </a:r>
+          </a:p>
+        </p:txBody>
+      </p:sp>
+      <p:sp>
+        <p:nvSpPr>
+          <p:cNvPr id="38" name="Rounded Rectangle 37"/>
           <p:cNvSpPr/>
           <p:nvPr/>
         </p:nvSpPr>
         <p:spPr>
           <a:xfrm>
-            <a:off x="9326880" y="6099048"/>
-            <a:ext cx="2679192" cy="658368"/>
+            <a:off x="5989320" y="6126480"/>
+            <a:ext cx="1783080" cy="621792"/>
           </a:xfrm>
           <a:prstGeom prst="roundRect">
             <a:avLst>
-              <a:gd name="adj" fmla="val 11111"/>
+              <a:gd name="adj" fmla="val 8000"/>
             </a:avLst>
           </a:prstGeom>
           <a:solidFill>
-            <a:srgbClr val="B45309"/>
+            <a:srgbClr val="92400E"/>
           </a:solidFill>
           <a:ln w="6350">
             <a:solidFill>
-              <a:srgbClr val="92400E"/>
+              <a:srgbClr val="B45309"/>
             </a:solidFill>
           </a:ln>
         </p:spPr>
@@ -5074,7 +4927,7 @@
           <a:p>
             <a:pPr algn="ctr"/>
             <a:r>
-              <a:rPr b="1" sz="900">
+              <a:rPr b="1" sz="850">
                 <a:solidFill>
                   <a:srgbClr val="FFFFFF"/>
                 </a:solidFill>
@@ -5092,7 +4945,395 @@
                 </a:solidFill>
                 <a:latin typeface="Calibri"/>
               </a:rPr>
-              <a:t>GPT-4o (chat)  •  text-embedding-3-large</a:t>
+              <a:t>GPT-4o • embeddings</a:t>
+            </a:r>
+          </a:p>
+        </p:txBody>
+      </p:sp>
+      <p:sp>
+        <p:nvSpPr>
+          <p:cNvPr id="39" name="Rounded Rectangle 38"/>
+          <p:cNvSpPr/>
+          <p:nvPr/>
+        </p:nvSpPr>
+        <p:spPr>
+          <a:xfrm>
+            <a:off x="7936992" y="320040"/>
+            <a:ext cx="4087368" cy="3017520"/>
+          </a:xfrm>
+          <a:prstGeom prst="roundRect">
+            <a:avLst>
+              <a:gd name="adj" fmla="val 6000"/>
+            </a:avLst>
+          </a:prstGeom>
+          <a:solidFill>
+            <a:srgbClr val="0D1F38"/>
+          </a:solidFill>
+          <a:ln w="9525">
+            <a:solidFill>
+              <a:srgbClr val="1F6FEB"/>
+            </a:solidFill>
+          </a:ln>
+        </p:spPr>
+        <p:style>
+          <a:lnRef idx="1">
+            <a:schemeClr val="accent1"/>
+          </a:lnRef>
+          <a:fillRef idx="3">
+            <a:schemeClr val="accent1"/>
+          </a:fillRef>
+          <a:effectRef idx="2">
+            <a:schemeClr val="accent1"/>
+          </a:effectRef>
+          <a:fontRef idx="minor">
+            <a:schemeClr val="lt1"/>
+          </a:fontRef>
+        </p:style>
+        <p:txBody anchor="t" marL="109728" marR="109728" marT="91440">
+          <a:bodyPr rtlCol="0" anchor="ctr" wrap="square"/>
+          <a:lstStyle/>
+          <a:p>
+            <a:pPr algn="l"/>
+            <a:r>
+              <a:rPr b="1" sz="1000">
+                <a:solidFill>
+                  <a:srgbClr val="79C0FF"/>
+                </a:solidFill>
+                <a:latin typeface="Calibri"/>
+              </a:rPr>
+              <a:t>Business Use Case</a:t>
+            </a:r>
+          </a:p>
+          <a:p>
+            <a:pPr algn="l"/>
+            <a:r>
+              <a:rPr b="0" sz="800">
+                <a:solidFill>
+                  <a:srgbClr val="C9D1D9"/>
+                </a:solidFill>
+                <a:latin typeface="Calibri"/>
+              </a:rPr>
+              <a:t/>
+            </a:r>
+          </a:p>
+          <a:p>
+            <a:pPr algn="l"/>
+            <a:r>
+              <a:rPr b="0" sz="800">
+                <a:solidFill>
+                  <a:srgbClr val="C9D1D9"/>
+                </a:solidFill>
+                <a:latin typeface="Calibri"/>
+              </a:rPr>
+              <a:t>Legal teams manage hundreds of contracts</a:t>
+            </a:r>
+          </a:p>
+          <a:p>
+            <a:pPr algn="l"/>
+            <a:r>
+              <a:rPr b="0" sz="800">
+                <a:solidFill>
+                  <a:srgbClr val="C9D1D9"/>
+                </a:solidFill>
+                <a:latin typeface="Calibri"/>
+              </a:rPr>
+              <a:t>manually — finding obligations or risk</a:t>
+            </a:r>
+          </a:p>
+          <a:p>
+            <a:pPr algn="l"/>
+            <a:r>
+              <a:rPr b="0" sz="800">
+                <a:solidFill>
+                  <a:srgbClr val="C9D1D9"/>
+                </a:solidFill>
+                <a:latin typeface="Calibri"/>
+              </a:rPr>
+              <a:t>clauses takes hours per document.</a:t>
+            </a:r>
+          </a:p>
+          <a:p>
+            <a:pPr algn="l"/>
+            <a:r>
+              <a:rPr b="0" sz="800">
+                <a:solidFill>
+                  <a:srgbClr val="C9D1D9"/>
+                </a:solidFill>
+                <a:latin typeface="Calibri"/>
+              </a:rPr>
+              <a:t/>
+            </a:r>
+          </a:p>
+          <a:p>
+            <a:pPr algn="l"/>
+            <a:r>
+              <a:rPr b="0" sz="800">
+                <a:solidFill>
+                  <a:srgbClr val="C9D1D9"/>
+                </a:solidFill>
+                <a:latin typeface="Calibri"/>
+              </a:rPr>
+              <a:t>Cross-contract comparison is nearly</a:t>
+            </a:r>
+          </a:p>
+          <a:p>
+            <a:pPr algn="l"/>
+            <a:r>
+              <a:rPr b="0" sz="800">
+                <a:solidFill>
+                  <a:srgbClr val="C9D1D9"/>
+                </a:solidFill>
+                <a:latin typeface="Calibri"/>
+              </a:rPr>
+              <a:t>impossible at scale, creating exposure</a:t>
+            </a:r>
+          </a:p>
+          <a:p>
+            <a:pPr algn="l"/>
+            <a:r>
+              <a:rPr b="0" sz="800">
+                <a:solidFill>
+                  <a:srgbClr val="C9D1D9"/>
+                </a:solidFill>
+                <a:latin typeface="Calibri"/>
+              </a:rPr>
+              <a:t>to missed deadlines and obligations.</a:t>
+            </a:r>
+          </a:p>
+          <a:p>
+            <a:pPr algn="l"/>
+            <a:r>
+              <a:rPr b="0" sz="800">
+                <a:solidFill>
+                  <a:srgbClr val="C9D1D9"/>
+                </a:solidFill>
+                <a:latin typeface="Calibri"/>
+              </a:rPr>
+              <a:t/>
+            </a:r>
+          </a:p>
+          <a:p>
+            <a:pPr algn="l"/>
+            <a:r>
+              <a:rPr b="0" sz="800">
+                <a:solidFill>
+                  <a:srgbClr val="C9D1D9"/>
+                </a:solidFill>
+                <a:latin typeface="Calibri"/>
+              </a:rPr>
+              <a:t>→  Ask any legal question across your</a:t>
+            </a:r>
+          </a:p>
+          <a:p>
+            <a:pPr algn="l"/>
+            <a:r>
+              <a:rPr b="0" sz="800">
+                <a:solidFill>
+                  <a:srgbClr val="C9D1D9"/>
+                </a:solidFill>
+                <a:latin typeface="Calibri"/>
+              </a:rPr>
+              <a:t>    entire contract portfolio and get</a:t>
+            </a:r>
+          </a:p>
+          <a:p>
+            <a:pPr algn="l"/>
+            <a:r>
+              <a:rPr b="0" sz="800">
+                <a:solidFill>
+                  <a:srgbClr val="C9D1D9"/>
+                </a:solidFill>
+                <a:latin typeface="Calibri"/>
+              </a:rPr>
+              <a:t>    cited, structured answers — instantly.</a:t>
+            </a:r>
+          </a:p>
+        </p:txBody>
+      </p:sp>
+      <p:sp>
+        <p:nvSpPr>
+          <p:cNvPr id="40" name="Rounded Rectangle 39"/>
+          <p:cNvSpPr/>
+          <p:nvPr/>
+        </p:nvSpPr>
+        <p:spPr>
+          <a:xfrm>
+            <a:off x="7936992" y="3456432"/>
+            <a:ext cx="4087368" cy="3291840"/>
+          </a:xfrm>
+          <a:prstGeom prst="roundRect">
+            <a:avLst>
+              <a:gd name="adj" fmla="val 6000"/>
+            </a:avLst>
+          </a:prstGeom>
+          <a:solidFill>
+            <a:srgbClr val="0D1F1A"/>
+          </a:solidFill>
+          <a:ln w="9525">
+            <a:solidFill>
+              <a:srgbClr val="238636"/>
+            </a:solidFill>
+          </a:ln>
+        </p:spPr>
+        <p:style>
+          <a:lnRef idx="1">
+            <a:schemeClr val="accent1"/>
+          </a:lnRef>
+          <a:fillRef idx="3">
+            <a:schemeClr val="accent1"/>
+          </a:fillRef>
+          <a:effectRef idx="2">
+            <a:schemeClr val="accent1"/>
+          </a:effectRef>
+          <a:fontRef idx="minor">
+            <a:schemeClr val="lt1"/>
+          </a:fontRef>
+        </p:style>
+        <p:txBody anchor="t" marL="109728" marR="109728" marT="91440">
+          <a:bodyPr rtlCol="0" anchor="ctr" wrap="square"/>
+          <a:lstStyle/>
+          <a:p>
+            <a:pPr algn="l"/>
+            <a:r>
+              <a:rPr b="1" sz="1000">
+                <a:solidFill>
+                  <a:srgbClr val="3FB950"/>
+                </a:solidFill>
+                <a:latin typeface="Calibri"/>
+              </a:rPr>
+              <a:t>Tech Stack</a:t>
+            </a:r>
+          </a:p>
+          <a:p>
+            <a:pPr algn="l"/>
+            <a:r>
+              <a:rPr b="0" sz="800">
+                <a:solidFill>
+                  <a:srgbClr val="C9D1D9"/>
+                </a:solidFill>
+                <a:latin typeface="Calibri"/>
+              </a:rPr>
+              <a:t/>
+            </a:r>
+          </a:p>
+          <a:p>
+            <a:pPr algn="l"/>
+            <a:r>
+              <a:rPr b="0" sz="800">
+                <a:solidFill>
+                  <a:srgbClr val="C9D1D9"/>
+                </a:solidFill>
+                <a:latin typeface="Calibri"/>
+              </a:rPr>
+              <a:t>Frontend    React (Vite) + TypeScript</a:t>
+            </a:r>
+          </a:p>
+          <a:p>
+            <a:pPr algn="l"/>
+            <a:r>
+              <a:rPr b="0" sz="800">
+                <a:solidFill>
+                  <a:srgbClr val="C9D1D9"/>
+                </a:solidFill>
+                <a:latin typeface="Calibri"/>
+              </a:rPr>
+              <a:t>Backend     FastAPI (Python) + Uvicorn</a:t>
+            </a:r>
+          </a:p>
+          <a:p>
+            <a:pPr algn="l"/>
+            <a:r>
+              <a:rPr b="0" sz="800">
+                <a:solidFill>
+                  <a:srgbClr val="C9D1D9"/>
+                </a:solidFill>
+                <a:latin typeface="Calibri"/>
+              </a:rPr>
+              <a:t>LLM           Azure OpenAI  GPT-4o</a:t>
+            </a:r>
+          </a:p>
+          <a:p>
+            <a:pPr algn="l"/>
+            <a:r>
+              <a:rPr b="0" sz="800">
+                <a:solidFill>
+                  <a:srgbClr val="C9D1D9"/>
+                </a:solidFill>
+                <a:latin typeface="Calibri"/>
+              </a:rPr>
+              <a:t>Embeddings  text-embedding-3-large</a:t>
+            </a:r>
+          </a:p>
+          <a:p>
+            <a:pPr algn="l"/>
+            <a:r>
+              <a:rPr b="0" sz="800">
+                <a:solidFill>
+                  <a:srgbClr val="C9D1D9"/>
+                </a:solidFill>
+                <a:latin typeface="Calibri"/>
+              </a:rPr>
+              <a:t>Search        Azure AI Search (BM25+vector)</a:t>
+            </a:r>
+          </a:p>
+          <a:p>
+            <a:pPr algn="l"/>
+            <a:r>
+              <a:rPr b="0" sz="800">
+                <a:solidFill>
+                  <a:srgbClr val="C9D1D9"/>
+                </a:solidFill>
+                <a:latin typeface="Calibri"/>
+              </a:rPr>
+              <a:t>Graph DB    Cosmos DB  Gremlin API</a:t>
+            </a:r>
+          </a:p>
+          <a:p>
+            <a:pPr algn="l"/>
+            <a:r>
+              <a:rPr b="0" sz="800">
+                <a:solidFill>
+                  <a:srgbClr val="C9D1D9"/>
+                </a:solidFill>
+                <a:latin typeface="Calibri"/>
+              </a:rPr>
+              <a:t>Session DB  Cosmos DB  NoSQL</a:t>
+            </a:r>
+          </a:p>
+          <a:p>
+            <a:pPr algn="l"/>
+            <a:r>
+              <a:rPr b="0" sz="800">
+                <a:solidFill>
+                  <a:srgbClr val="C9D1D9"/>
+                </a:solidFill>
+                <a:latin typeface="Calibri"/>
+              </a:rPr>
+              <a:t>Storage      Azure Blob Storage</a:t>
+            </a:r>
+          </a:p>
+          <a:p>
+            <a:pPr algn="l"/>
+            <a:r>
+              <a:rPr b="0" sz="800">
+                <a:solidFill>
+                  <a:srgbClr val="C9D1D9"/>
+                </a:solidFill>
+                <a:latin typeface="Calibri"/>
+              </a:rPr>
+              <a:t>Doc Parse   Azure Document Intelligence</a:t>
+            </a:r>
+          </a:p>
+          <a:p>
+            <a:pPr algn="l"/>
+            <a:r>
+              <a:rPr b="0" sz="800">
+                <a:solidFill>
+                  <a:srgbClr val="C9D1D9"/>
+                </a:solidFill>
+                <a:latin typeface="Calibri"/>
+              </a:rPr>
+              <a:t>Deploy       Docker  +  Azure Container Apps</a:t>
             </a:r>
           </a:p>
         </p:txBody>

</xml_diff>